<commit_message>
Make roadmap flowchart horizontal, add presentation speaker script
Redraws the research roadmap diagram as a left-to-right six-stage flow
(matching the system-architecture diagram's visual style) instead of a
vertical stack, resizes its slide placement in the deck accordingly,
and adds a slide-by-slide speaker script with timing and anticipated
Q&A for presenting the deck.

Co-Authored-By: Claude Sonnet 5 <noreply@anthropic.com>
Claude-Session: https://claude.ai/code/session_013bkUXKvQooBnkHzdEiYFy5
</commit_message>
<xml_diff>
--- a/docs/research-proposal/Process-Aware_Authenticity_Detection_Presentation.pptx
+++ b/docs/research-proposal/Process-Aware_Authenticity_Detection_Presentation.pptx
@@ -4080,8 +4080,8 @@
         </p:blipFill>
         <p:spPr>
           <a:xfrm>
-            <a:off x="3784581" y="1417320"/>
-            <a:ext cx="4622532" cy="5166360"/>
+            <a:off x="472287" y="2651760"/>
+            <a:ext cx="11247120" cy="2550893"/>
           </a:xfrm>
           <a:prstGeom prst="rect">
             <a:avLst/>

</xml_diff>

<commit_message>
Update presentation author name to Rohandeep
Co-Authored-By: Claude Sonnet 5 <noreply@anthropic.com>
Claude-Session: https://claude.ai/code/session_013bkUXKvQooBnkHzdEiYFy5
</commit_message>
<xml_diff>
--- a/docs/research-proposal/Process-Aware_Authenticity_Detection_Presentation.pptx
+++ b/docs/research-proposal/Process-Aware_Authenticity_Detection_Presentation.pptx
@@ -3296,7 +3296,7 @@
                 </a:solidFill>
                 <a:latin typeface="Calibri"/>
               </a:rPr>
-              <a:t>M.Tech Research Proposal  ·  CodeHamsters, M.Tech CSE  ·  IIIT Surat</a:t>
+              <a:t>M.Tech Research Proposal  ·  Rohandeep, M.Tech CSE  ·  IIIT Surat</a:t>
             </a:r>
           </a:p>
         </p:txBody>
@@ -5129,7 +5129,7 @@
                 </a:solidFill>
                 <a:latin typeface="Calibri"/>
               </a:rPr>
-              <a:t>CodeHamsters, M.Tech CSE  ·  IIIT Surat</a:t>
+              <a:t>Rohandeep, M.Tech CSE  ·  IIIT Surat</a:t>
             </a:r>
           </a:p>
         </p:txBody>

</xml_diff>